<commit_message>
Replace emoji icons with Bootstrap Icons in trainer presentation
Feature cards and the warning marker now use rendered Bootstrap Icons
(calendar, clipboard-check, bar-chart, exclamation-triangle) instead of
emoji glyphs, for a more consistent professional look.

Co-Authored-By: Claude Sonnet 5 <noreply@anthropic.com>
Claude-Session: https://claude.ai/code/session_01VQE6ji7GvDAzbi3tH7Cjmm
</commit_message>
<xml_diff>
--- a/docs/trainer-guide/Okurmen_KIDS_LMS_instrukciya_dlya_trenerov.pptx
+++ b/docs/trainer-guide/Okurmen_KIDS_LMS_instrukciya_dlya_trenerov.pptx
@@ -5364,48 +5364,33 @@
           <a:ln/>
         </p:spPr>
       </p:sp>
-      <p:sp>
-        <p:nvSpPr>
-          <p:cNvPr id="7" name="Text 5"/>
-          <p:cNvSpPr txBox="1"/>
-          <p:nvPr/>
-        </p:nvSpPr>
-        <p:spPr>
-          <a:xfrm>
-            <a:off x="731520" y="2011680"/>
-            <a:ext cx="347472" cy="347472"/>
-          </a:xfrm>
-          <a:prstGeom prst="rect">
-            <a:avLst/>
-          </a:prstGeom>
-          <a:noFill/>
-          <a:ln/>
-        </p:spPr>
-        <p:txBody>
-          <a:bodyPr wrap="square" lIns="0" tIns="0" rIns="0" bIns="0" rtlCol="0" anchor="ctr"/>
-          <a:lstStyle/>
-          <a:p>
-            <a:pPr algn="ctr" indent="0" marL="0">
-              <a:buNone/>
-            </a:pPr>
-            <a:r>
-              <a:rPr lang="en-US" sz="1600" b="1" dirty="0">
-                <a:solidFill>
-                  <a:srgbClr val="FFFFFF"/>
-                </a:solidFill>
-                <a:latin typeface="Calibri" pitchFamily="34" charset="0"/>
-                <a:ea typeface="Calibri" pitchFamily="34" charset="-122"/>
-                <a:cs typeface="Calibri" pitchFamily="34" charset="-120"/>
-              </a:rPr>
-              <a:t>!</a:t>
-            </a:r>
-            <a:endParaRPr lang="en-US" sz="1600" dirty="0"/>
-          </a:p>
-        </p:txBody>
-      </p:sp>
-      <p:sp>
-        <p:nvSpPr>
-          <p:cNvPr id="8" name="Text 6"/>
+      <p:pic>
+        <p:nvPicPr>
+          <p:cNvPr id="7" name="Image 0" descr="/tmp/claude-0/scratchpad/shots/cropped/ic_warning.png">    </p:cNvPr>
+          <p:cNvPicPr>
+            <a:picLocks noChangeAspect="1"/>
+          </p:cNvPicPr>
+          <p:nvPr/>
+        </p:nvPicPr>
+        <p:blipFill>
+          <a:blip r:embed="rId1"/>
+          <a:stretch>
+            <a:fillRect/>
+          </a:stretch>
+        </p:blipFill>
+        <p:spPr>
+          <a:xfrm>
+            <a:off x="825337" y="2105497"/>
+            <a:ext cx="159837" cy="159837"/>
+          </a:xfrm>
+          <a:prstGeom prst="rect">
+            <a:avLst/>
+          </a:prstGeom>
+        </p:spPr>
+      </p:pic>
+      <p:sp>
+        <p:nvSpPr>
+          <p:cNvPr id="8" name="Text 5"/>
           <p:cNvSpPr txBox="1"/>
           <p:nvPr/>
         </p:nvSpPr>
@@ -5447,7 +5432,7 @@
       </p:sp>
       <p:sp>
         <p:nvSpPr>
-          <p:cNvPr id="9" name="Text 7"/>
+          <p:cNvPr id="9" name="Text 6"/>
           <p:cNvSpPr txBox="1"/>
           <p:nvPr/>
         </p:nvSpPr>
@@ -5489,7 +5474,7 @@
       </p:sp>
       <p:sp>
         <p:nvSpPr>
-          <p:cNvPr id="10" name="Shape 8"/>
+          <p:cNvPr id="10" name="Shape 7"/>
           <p:cNvSpPr/>
           <p:nvPr/>
         </p:nvSpPr>
@@ -5511,7 +5496,7 @@
       </p:sp>
       <p:sp>
         <p:nvSpPr>
-          <p:cNvPr id="11" name="Shape 9"/>
+          <p:cNvPr id="11" name="Shape 8"/>
           <p:cNvSpPr/>
           <p:nvPr/>
         </p:nvSpPr>
@@ -5529,48 +5514,33 @@
           <a:ln/>
         </p:spPr>
       </p:sp>
-      <p:sp>
-        <p:nvSpPr>
-          <p:cNvPr id="12" name="Text 10"/>
-          <p:cNvSpPr txBox="1"/>
-          <p:nvPr/>
-        </p:nvSpPr>
-        <p:spPr>
-          <a:xfrm>
-            <a:off x="731520" y="2852928"/>
-            <a:ext cx="347472" cy="347472"/>
-          </a:xfrm>
-          <a:prstGeom prst="rect">
-            <a:avLst/>
-          </a:prstGeom>
-          <a:noFill/>
-          <a:ln/>
-        </p:spPr>
-        <p:txBody>
-          <a:bodyPr wrap="square" lIns="0" tIns="0" rIns="0" bIns="0" rtlCol="0" anchor="ctr"/>
-          <a:lstStyle/>
-          <a:p>
-            <a:pPr algn="ctr" indent="0" marL="0">
-              <a:buNone/>
-            </a:pPr>
-            <a:r>
-              <a:rPr lang="en-US" sz="1600" b="1" dirty="0">
-                <a:solidFill>
-                  <a:srgbClr val="FFFFFF"/>
-                </a:solidFill>
-                <a:latin typeface="Calibri" pitchFamily="34" charset="0"/>
-                <a:ea typeface="Calibri" pitchFamily="34" charset="-122"/>
-                <a:cs typeface="Calibri" pitchFamily="34" charset="-120"/>
-              </a:rPr>
-              <a:t>!</a:t>
-            </a:r>
-            <a:endParaRPr lang="en-US" sz="1600" dirty="0"/>
-          </a:p>
-        </p:txBody>
-      </p:sp>
-      <p:sp>
-        <p:nvSpPr>
-          <p:cNvPr id="13" name="Text 11"/>
+      <p:pic>
+        <p:nvPicPr>
+          <p:cNvPr id="12" name="Image 1" descr="/tmp/claude-0/scratchpad/shots/cropped/ic_warning.png">    </p:cNvPr>
+          <p:cNvPicPr>
+            <a:picLocks noChangeAspect="1"/>
+          </p:cNvPicPr>
+          <p:nvPr/>
+        </p:nvPicPr>
+        <p:blipFill>
+          <a:blip r:embed="rId2"/>
+          <a:stretch>
+            <a:fillRect/>
+          </a:stretch>
+        </p:blipFill>
+        <p:spPr>
+          <a:xfrm>
+            <a:off x="825337" y="2946745"/>
+            <a:ext cx="159837" cy="159837"/>
+          </a:xfrm>
+          <a:prstGeom prst="rect">
+            <a:avLst/>
+          </a:prstGeom>
+        </p:spPr>
+      </p:pic>
+      <p:sp>
+        <p:nvSpPr>
+          <p:cNvPr id="13" name="Text 9"/>
           <p:cNvSpPr txBox="1"/>
           <p:nvPr/>
         </p:nvSpPr>
@@ -5612,7 +5582,7 @@
       </p:sp>
       <p:sp>
         <p:nvSpPr>
-          <p:cNvPr id="14" name="Text 12"/>
+          <p:cNvPr id="14" name="Text 10"/>
           <p:cNvSpPr txBox="1"/>
           <p:nvPr/>
         </p:nvSpPr>
@@ -5654,7 +5624,7 @@
       </p:sp>
       <p:sp>
         <p:nvSpPr>
-          <p:cNvPr id="15" name="Shape 13"/>
+          <p:cNvPr id="15" name="Shape 11"/>
           <p:cNvSpPr/>
           <p:nvPr/>
         </p:nvSpPr>
@@ -5676,7 +5646,7 @@
       </p:sp>
       <p:sp>
         <p:nvSpPr>
-          <p:cNvPr id="16" name="Shape 14"/>
+          <p:cNvPr id="16" name="Shape 12"/>
           <p:cNvSpPr/>
           <p:nvPr/>
         </p:nvSpPr>
@@ -5694,48 +5664,33 @@
           <a:ln/>
         </p:spPr>
       </p:sp>
-      <p:sp>
-        <p:nvSpPr>
-          <p:cNvPr id="17" name="Text 15"/>
-          <p:cNvSpPr txBox="1"/>
-          <p:nvPr/>
-        </p:nvSpPr>
-        <p:spPr>
-          <a:xfrm>
-            <a:off x="731520" y="3694176"/>
-            <a:ext cx="347472" cy="347472"/>
-          </a:xfrm>
-          <a:prstGeom prst="rect">
-            <a:avLst/>
-          </a:prstGeom>
-          <a:noFill/>
-          <a:ln/>
-        </p:spPr>
-        <p:txBody>
-          <a:bodyPr wrap="square" lIns="0" tIns="0" rIns="0" bIns="0" rtlCol="0" anchor="ctr"/>
-          <a:lstStyle/>
-          <a:p>
-            <a:pPr algn="ctr" indent="0" marL="0">
-              <a:buNone/>
-            </a:pPr>
-            <a:r>
-              <a:rPr lang="en-US" sz="1600" b="1" dirty="0">
-                <a:solidFill>
-                  <a:srgbClr val="FFFFFF"/>
-                </a:solidFill>
-                <a:latin typeface="Calibri" pitchFamily="34" charset="0"/>
-                <a:ea typeface="Calibri" pitchFamily="34" charset="-122"/>
-                <a:cs typeface="Calibri" pitchFamily="34" charset="-120"/>
-              </a:rPr>
-              <a:t>!</a:t>
-            </a:r>
-            <a:endParaRPr lang="en-US" sz="1600" dirty="0"/>
-          </a:p>
-        </p:txBody>
-      </p:sp>
-      <p:sp>
-        <p:nvSpPr>
-          <p:cNvPr id="18" name="Text 16"/>
+      <p:pic>
+        <p:nvPicPr>
+          <p:cNvPr id="17" name="Image 2" descr="/tmp/claude-0/scratchpad/shots/cropped/ic_warning.png">    </p:cNvPr>
+          <p:cNvPicPr>
+            <a:picLocks noChangeAspect="1"/>
+          </p:cNvPicPr>
+          <p:nvPr/>
+        </p:nvPicPr>
+        <p:blipFill>
+          <a:blip r:embed="rId3"/>
+          <a:stretch>
+            <a:fillRect/>
+          </a:stretch>
+        </p:blipFill>
+        <p:spPr>
+          <a:xfrm>
+            <a:off x="825337" y="3787993"/>
+            <a:ext cx="159837" cy="159837"/>
+          </a:xfrm>
+          <a:prstGeom prst="rect">
+            <a:avLst/>
+          </a:prstGeom>
+        </p:spPr>
+      </p:pic>
+      <p:sp>
+        <p:nvSpPr>
+          <p:cNvPr id="18" name="Text 13"/>
           <p:cNvSpPr txBox="1"/>
           <p:nvPr/>
         </p:nvSpPr>
@@ -5777,7 +5732,7 @@
       </p:sp>
       <p:sp>
         <p:nvSpPr>
-          <p:cNvPr id="19" name="Text 17"/>
+          <p:cNvPr id="19" name="Text 14"/>
           <p:cNvSpPr txBox="1"/>
           <p:nvPr/>
         </p:nvSpPr>
@@ -5819,7 +5774,7 @@
       </p:sp>
       <p:sp>
         <p:nvSpPr>
-          <p:cNvPr id="20" name="Shape 18"/>
+          <p:cNvPr id="20" name="Shape 15"/>
           <p:cNvSpPr/>
           <p:nvPr/>
         </p:nvSpPr>
@@ -5841,7 +5796,7 @@
       </p:sp>
       <p:sp>
         <p:nvSpPr>
-          <p:cNvPr id="21" name="Shape 19"/>
+          <p:cNvPr id="21" name="Shape 16"/>
           <p:cNvSpPr/>
           <p:nvPr/>
         </p:nvSpPr>
@@ -5859,48 +5814,33 @@
           <a:ln/>
         </p:spPr>
       </p:sp>
-      <p:sp>
-        <p:nvSpPr>
-          <p:cNvPr id="22" name="Text 20"/>
-          <p:cNvSpPr txBox="1"/>
-          <p:nvPr/>
-        </p:nvSpPr>
-        <p:spPr>
-          <a:xfrm>
-            <a:off x="731520" y="4535424"/>
-            <a:ext cx="347472" cy="347472"/>
-          </a:xfrm>
-          <a:prstGeom prst="rect">
-            <a:avLst/>
-          </a:prstGeom>
-          <a:noFill/>
-          <a:ln/>
-        </p:spPr>
-        <p:txBody>
-          <a:bodyPr wrap="square" lIns="0" tIns="0" rIns="0" bIns="0" rtlCol="0" anchor="ctr"/>
-          <a:lstStyle/>
-          <a:p>
-            <a:pPr algn="ctr" indent="0" marL="0">
-              <a:buNone/>
-            </a:pPr>
-            <a:r>
-              <a:rPr lang="en-US" sz="1600" b="1" dirty="0">
-                <a:solidFill>
-                  <a:srgbClr val="FFFFFF"/>
-                </a:solidFill>
-                <a:latin typeface="Calibri" pitchFamily="34" charset="0"/>
-                <a:ea typeface="Calibri" pitchFamily="34" charset="-122"/>
-                <a:cs typeface="Calibri" pitchFamily="34" charset="-120"/>
-              </a:rPr>
-              <a:t>!</a:t>
-            </a:r>
-            <a:endParaRPr lang="en-US" sz="1600" dirty="0"/>
-          </a:p>
-        </p:txBody>
-      </p:sp>
-      <p:sp>
-        <p:nvSpPr>
-          <p:cNvPr id="23" name="Text 21"/>
+      <p:pic>
+        <p:nvPicPr>
+          <p:cNvPr id="22" name="Image 3" descr="/tmp/claude-0/scratchpad/shots/cropped/ic_warning.png">    </p:cNvPr>
+          <p:cNvPicPr>
+            <a:picLocks noChangeAspect="1"/>
+          </p:cNvPicPr>
+          <p:nvPr/>
+        </p:nvPicPr>
+        <p:blipFill>
+          <a:blip r:embed="rId4"/>
+          <a:stretch>
+            <a:fillRect/>
+          </a:stretch>
+        </p:blipFill>
+        <p:spPr>
+          <a:xfrm>
+            <a:off x="825337" y="4629241"/>
+            <a:ext cx="159837" cy="159837"/>
+          </a:xfrm>
+          <a:prstGeom prst="rect">
+            <a:avLst/>
+          </a:prstGeom>
+        </p:spPr>
+      </p:pic>
+      <p:sp>
+        <p:nvSpPr>
+          <p:cNvPr id="23" name="Text 17"/>
           <p:cNvSpPr txBox="1"/>
           <p:nvPr/>
         </p:nvSpPr>
@@ -5942,7 +5882,7 @@
       </p:sp>
       <p:sp>
         <p:nvSpPr>
-          <p:cNvPr id="24" name="Text 22"/>
+          <p:cNvPr id="24" name="Text 18"/>
           <p:cNvSpPr txBox="1"/>
           <p:nvPr/>
         </p:nvSpPr>
@@ -5984,7 +5924,7 @@
       </p:sp>
       <p:sp>
         <p:nvSpPr>
-          <p:cNvPr id="25" name="Shape 23"/>
+          <p:cNvPr id="25" name="Shape 19"/>
           <p:cNvSpPr/>
           <p:nvPr/>
         </p:nvSpPr>
@@ -6006,7 +5946,7 @@
       </p:sp>
       <p:sp>
         <p:nvSpPr>
-          <p:cNvPr id="26" name="Shape 24"/>
+          <p:cNvPr id="26" name="Shape 20"/>
           <p:cNvSpPr/>
           <p:nvPr/>
         </p:nvSpPr>
@@ -6024,48 +5964,33 @@
           <a:ln/>
         </p:spPr>
       </p:sp>
-      <p:sp>
-        <p:nvSpPr>
-          <p:cNvPr id="27" name="Text 25"/>
-          <p:cNvSpPr txBox="1"/>
-          <p:nvPr/>
-        </p:nvSpPr>
-        <p:spPr>
-          <a:xfrm>
-            <a:off x="731520" y="5376672"/>
-            <a:ext cx="347472" cy="347472"/>
-          </a:xfrm>
-          <a:prstGeom prst="rect">
-            <a:avLst/>
-          </a:prstGeom>
-          <a:noFill/>
-          <a:ln/>
-        </p:spPr>
-        <p:txBody>
-          <a:bodyPr wrap="square" lIns="0" tIns="0" rIns="0" bIns="0" rtlCol="0" anchor="ctr"/>
-          <a:lstStyle/>
-          <a:p>
-            <a:pPr algn="ctr" indent="0" marL="0">
-              <a:buNone/>
-            </a:pPr>
-            <a:r>
-              <a:rPr lang="en-US" sz="1600" b="1" dirty="0">
-                <a:solidFill>
-                  <a:srgbClr val="FFFFFF"/>
-                </a:solidFill>
-                <a:latin typeface="Calibri" pitchFamily="34" charset="0"/>
-                <a:ea typeface="Calibri" pitchFamily="34" charset="-122"/>
-                <a:cs typeface="Calibri" pitchFamily="34" charset="-120"/>
-              </a:rPr>
-              <a:t>!</a:t>
-            </a:r>
-            <a:endParaRPr lang="en-US" sz="1600" dirty="0"/>
-          </a:p>
-        </p:txBody>
-      </p:sp>
-      <p:sp>
-        <p:nvSpPr>
-          <p:cNvPr id="28" name="Text 26"/>
+      <p:pic>
+        <p:nvPicPr>
+          <p:cNvPr id="27" name="Image 4" descr="/tmp/claude-0/scratchpad/shots/cropped/ic_warning.png">    </p:cNvPr>
+          <p:cNvPicPr>
+            <a:picLocks noChangeAspect="1"/>
+          </p:cNvPicPr>
+          <p:nvPr/>
+        </p:nvPicPr>
+        <p:blipFill>
+          <a:blip r:embed="rId5"/>
+          <a:stretch>
+            <a:fillRect/>
+          </a:stretch>
+        </p:blipFill>
+        <p:spPr>
+          <a:xfrm>
+            <a:off x="825337" y="5470489"/>
+            <a:ext cx="159837" cy="159837"/>
+          </a:xfrm>
+          <a:prstGeom prst="rect">
+            <a:avLst/>
+          </a:prstGeom>
+        </p:spPr>
+      </p:pic>
+      <p:sp>
+        <p:nvSpPr>
+          <p:cNvPr id="28" name="Text 21"/>
           <p:cNvSpPr txBox="1"/>
           <p:nvPr/>
         </p:nvSpPr>
@@ -6107,7 +6032,7 @@
       </p:sp>
       <p:sp>
         <p:nvSpPr>
-          <p:cNvPr id="29" name="Text 27"/>
+          <p:cNvPr id="29" name="Text 22"/>
           <p:cNvSpPr txBox="1"/>
           <p:nvPr/>
         </p:nvSpPr>
@@ -6149,7 +6074,7 @@
       </p:sp>
       <p:sp>
         <p:nvSpPr>
-          <p:cNvPr id="30" name="Text 28"/>
+          <p:cNvPr id="30" name="Text 23"/>
           <p:cNvSpPr txBox="1"/>
           <p:nvPr/>
         </p:nvSpPr>
@@ -6188,7 +6113,7 @@
       </p:sp>
       <p:sp>
         <p:nvSpPr>
-          <p:cNvPr id="31" name="Text 29"/>
+          <p:cNvPr id="31" name="Text 24"/>
           <p:cNvSpPr txBox="1"/>
           <p:nvPr/>
         </p:nvSpPr>
@@ -8453,48 +8378,33 @@
           <a:ln/>
         </p:spPr>
       </p:sp>
-      <p:sp>
-        <p:nvSpPr>
-          <p:cNvPr id="7" name="Text 5"/>
-          <p:cNvSpPr txBox="1"/>
-          <p:nvPr/>
-        </p:nvSpPr>
-        <p:spPr>
-          <a:xfrm>
-            <a:off x="777240" y="2240280"/>
-            <a:ext cx="548640" cy="548640"/>
-          </a:xfrm>
-          <a:prstGeom prst="rect">
-            <a:avLst/>
-          </a:prstGeom>
-          <a:noFill/>
-          <a:ln/>
-        </p:spPr>
-        <p:txBody>
-          <a:bodyPr wrap="square" lIns="0" tIns="0" rIns="0" bIns="0" rtlCol="0" anchor="ctr"/>
-          <a:lstStyle/>
-          <a:p>
-            <a:pPr algn="ctr" indent="0" marL="0">
-              <a:buNone/>
-            </a:pPr>
-            <a:r>
-              <a:rPr lang="en-US" sz="2200" b="1" dirty="0">
-                <a:solidFill>
-                  <a:srgbClr val="FFFFFF"/>
-                </a:solidFill>
-                <a:latin typeface="Calibri" pitchFamily="34" charset="0"/>
-                <a:ea typeface="Calibri" pitchFamily="34" charset="-122"/>
-                <a:cs typeface="Calibri" pitchFamily="34" charset="-120"/>
-              </a:rPr>
-              <a:t>📅</a:t>
-            </a:r>
-            <a:endParaRPr lang="en-US" sz="2200" dirty="0"/>
-          </a:p>
-        </p:txBody>
-      </p:sp>
-      <p:sp>
-        <p:nvSpPr>
-          <p:cNvPr id="8" name="Text 6"/>
+      <p:pic>
+        <p:nvPicPr>
+          <p:cNvPr id="7" name="Image 0" descr="/tmp/claude-0/scratchpad/shots/cropped/ic_calendar.png">    </p:cNvPr>
+          <p:cNvPicPr>
+            <a:picLocks noChangeAspect="1"/>
+          </p:cNvPicPr>
+          <p:nvPr/>
+        </p:nvPicPr>
+        <p:blipFill>
+          <a:blip r:embed="rId1"/>
+          <a:stretch>
+            <a:fillRect/>
+          </a:stretch>
+        </p:blipFill>
+        <p:spPr>
+          <a:xfrm>
+            <a:off x="925373" y="2388413"/>
+            <a:ext cx="252374" cy="252374"/>
+          </a:xfrm>
+          <a:prstGeom prst="rect">
+            <a:avLst/>
+          </a:prstGeom>
+        </p:spPr>
+      </p:pic>
+      <p:sp>
+        <p:nvSpPr>
+          <p:cNvPr id="8" name="Text 5"/>
           <p:cNvSpPr txBox="1"/>
           <p:nvPr/>
         </p:nvSpPr>
@@ -8533,7 +8443,7 @@
       </p:sp>
       <p:sp>
         <p:nvSpPr>
-          <p:cNvPr id="9" name="Text 7"/>
+          <p:cNvPr id="9" name="Text 6"/>
           <p:cNvSpPr txBox="1"/>
           <p:nvPr/>
         </p:nvSpPr>
@@ -8575,7 +8485,7 @@
       </p:sp>
       <p:sp>
         <p:nvSpPr>
-          <p:cNvPr id="10" name="Shape 8"/>
+          <p:cNvPr id="10" name="Shape 7"/>
           <p:cNvSpPr/>
           <p:nvPr/>
         </p:nvSpPr>
@@ -8597,7 +8507,7 @@
       </p:sp>
       <p:sp>
         <p:nvSpPr>
-          <p:cNvPr id="11" name="Shape 9"/>
+          <p:cNvPr id="11" name="Shape 8"/>
           <p:cNvSpPr/>
           <p:nvPr/>
         </p:nvSpPr>
@@ -8615,48 +8525,33 @@
           <a:ln/>
         </p:spPr>
       </p:sp>
-      <p:sp>
-        <p:nvSpPr>
-          <p:cNvPr id="12" name="Text 10"/>
-          <p:cNvSpPr txBox="1"/>
-          <p:nvPr/>
-        </p:nvSpPr>
-        <p:spPr>
-          <a:xfrm>
-            <a:off x="4572000" y="2240280"/>
-            <a:ext cx="548640" cy="548640"/>
-          </a:xfrm>
-          <a:prstGeom prst="rect">
-            <a:avLst/>
-          </a:prstGeom>
-          <a:noFill/>
-          <a:ln/>
-        </p:spPr>
-        <p:txBody>
-          <a:bodyPr wrap="square" lIns="0" tIns="0" rIns="0" bIns="0" rtlCol="0" anchor="ctr"/>
-          <a:lstStyle/>
-          <a:p>
-            <a:pPr algn="ctr" indent="0" marL="0">
-              <a:buNone/>
-            </a:pPr>
-            <a:r>
-              <a:rPr lang="en-US" sz="2200" b="1" dirty="0">
-                <a:solidFill>
-                  <a:srgbClr val="FFFFFF"/>
-                </a:solidFill>
-                <a:latin typeface="Calibri" pitchFamily="34" charset="0"/>
-                <a:ea typeface="Calibri" pitchFamily="34" charset="-122"/>
-                <a:cs typeface="Calibri" pitchFamily="34" charset="-120"/>
-              </a:rPr>
-              <a:t>✅</a:t>
-            </a:r>
-            <a:endParaRPr lang="en-US" sz="2200" dirty="0"/>
-          </a:p>
-        </p:txBody>
-      </p:sp>
-      <p:sp>
-        <p:nvSpPr>
-          <p:cNvPr id="13" name="Text 11"/>
+      <p:pic>
+        <p:nvPicPr>
+          <p:cNvPr id="12" name="Image 1" descr="/tmp/claude-0/scratchpad/shots/cropped/ic_clipboard.png">    </p:cNvPr>
+          <p:cNvPicPr>
+            <a:picLocks noChangeAspect="1"/>
+          </p:cNvPicPr>
+          <p:nvPr/>
+        </p:nvPicPr>
+        <p:blipFill>
+          <a:blip r:embed="rId2"/>
+          <a:stretch>
+            <a:fillRect/>
+          </a:stretch>
+        </p:blipFill>
+        <p:spPr>
+          <a:xfrm>
+            <a:off x="4720133" y="2388413"/>
+            <a:ext cx="252374" cy="252374"/>
+          </a:xfrm>
+          <a:prstGeom prst="rect">
+            <a:avLst/>
+          </a:prstGeom>
+        </p:spPr>
+      </p:pic>
+      <p:sp>
+        <p:nvSpPr>
+          <p:cNvPr id="13" name="Text 9"/>
           <p:cNvSpPr txBox="1"/>
           <p:nvPr/>
         </p:nvSpPr>
@@ -8695,7 +8590,7 @@
       </p:sp>
       <p:sp>
         <p:nvSpPr>
-          <p:cNvPr id="14" name="Text 12"/>
+          <p:cNvPr id="14" name="Text 10"/>
           <p:cNvSpPr txBox="1"/>
           <p:nvPr/>
         </p:nvSpPr>
@@ -8737,7 +8632,7 @@
       </p:sp>
       <p:sp>
         <p:nvSpPr>
-          <p:cNvPr id="15" name="Shape 13"/>
+          <p:cNvPr id="15" name="Shape 11"/>
           <p:cNvSpPr/>
           <p:nvPr/>
         </p:nvSpPr>
@@ -8759,7 +8654,7 @@
       </p:sp>
       <p:sp>
         <p:nvSpPr>
-          <p:cNvPr id="16" name="Shape 14"/>
+          <p:cNvPr id="16" name="Shape 12"/>
           <p:cNvSpPr/>
           <p:nvPr/>
         </p:nvSpPr>
@@ -8777,48 +8672,33 @@
           <a:ln/>
         </p:spPr>
       </p:sp>
-      <p:sp>
-        <p:nvSpPr>
-          <p:cNvPr id="17" name="Text 15"/>
-          <p:cNvSpPr txBox="1"/>
-          <p:nvPr/>
-        </p:nvSpPr>
-        <p:spPr>
-          <a:xfrm>
-            <a:off x="8366760" y="2240280"/>
-            <a:ext cx="548640" cy="548640"/>
-          </a:xfrm>
-          <a:prstGeom prst="rect">
-            <a:avLst/>
-          </a:prstGeom>
-          <a:noFill/>
-          <a:ln/>
-        </p:spPr>
-        <p:txBody>
-          <a:bodyPr wrap="square" lIns="0" tIns="0" rIns="0" bIns="0" rtlCol="0" anchor="ctr"/>
-          <a:lstStyle/>
-          <a:p>
-            <a:pPr algn="ctr" indent="0" marL="0">
-              <a:buNone/>
-            </a:pPr>
-            <a:r>
-              <a:rPr lang="en-US" sz="2200" b="1" dirty="0">
-                <a:solidFill>
-                  <a:srgbClr val="FFFFFF"/>
-                </a:solidFill>
-                <a:latin typeface="Calibri" pitchFamily="34" charset="0"/>
-                <a:ea typeface="Calibri" pitchFamily="34" charset="-122"/>
-                <a:cs typeface="Calibri" pitchFamily="34" charset="-120"/>
-              </a:rPr>
-              <a:t>📊</a:t>
-            </a:r>
-            <a:endParaRPr lang="en-US" sz="2200" dirty="0"/>
-          </a:p>
-        </p:txBody>
-      </p:sp>
-      <p:sp>
-        <p:nvSpPr>
-          <p:cNvPr id="18" name="Text 16"/>
+      <p:pic>
+        <p:nvPicPr>
+          <p:cNvPr id="17" name="Image 2" descr="/tmp/claude-0/scratchpad/shots/cropped/ic_barchart.png">    </p:cNvPr>
+          <p:cNvPicPr>
+            <a:picLocks noChangeAspect="1"/>
+          </p:cNvPicPr>
+          <p:nvPr/>
+        </p:nvPicPr>
+        <p:blipFill>
+          <a:blip r:embed="rId3"/>
+          <a:stretch>
+            <a:fillRect/>
+          </a:stretch>
+        </p:blipFill>
+        <p:spPr>
+          <a:xfrm>
+            <a:off x="8514893" y="2388413"/>
+            <a:ext cx="252374" cy="252374"/>
+          </a:xfrm>
+          <a:prstGeom prst="rect">
+            <a:avLst/>
+          </a:prstGeom>
+        </p:spPr>
+      </p:pic>
+      <p:sp>
+        <p:nvSpPr>
+          <p:cNvPr id="18" name="Text 13"/>
           <p:cNvSpPr txBox="1"/>
           <p:nvPr/>
         </p:nvSpPr>
@@ -8857,7 +8737,7 @@
       </p:sp>
       <p:sp>
         <p:nvSpPr>
-          <p:cNvPr id="19" name="Text 17"/>
+          <p:cNvPr id="19" name="Text 14"/>
           <p:cNvSpPr txBox="1"/>
           <p:nvPr/>
         </p:nvSpPr>
@@ -8899,7 +8779,7 @@
       </p:sp>
       <p:sp>
         <p:nvSpPr>
-          <p:cNvPr id="20" name="Shape 18"/>
+          <p:cNvPr id="20" name="Shape 15"/>
           <p:cNvSpPr/>
           <p:nvPr/>
         </p:nvSpPr>
@@ -8926,7 +8806,7 @@
       </p:sp>
       <p:sp>
         <p:nvSpPr>
-          <p:cNvPr id="21" name="Text 19"/>
+          <p:cNvPr id="21" name="Text 16"/>
           <p:cNvSpPr txBox="1"/>
           <p:nvPr/>
         </p:nvSpPr>
@@ -8965,7 +8845,7 @@
       </p:sp>
       <p:sp>
         <p:nvSpPr>
-          <p:cNvPr id="22" name="Text 20"/>
+          <p:cNvPr id="22" name="Text 17"/>
           <p:cNvSpPr txBox="1"/>
           <p:nvPr/>
         </p:nvSpPr>
@@ -9007,7 +8887,7 @@
       </p:sp>
       <p:sp>
         <p:nvSpPr>
-          <p:cNvPr id="23" name="Text 21"/>
+          <p:cNvPr id="23" name="Text 18"/>
           <p:cNvSpPr txBox="1"/>
           <p:nvPr/>
         </p:nvSpPr>
@@ -9046,7 +8926,7 @@
       </p:sp>
       <p:sp>
         <p:nvSpPr>
-          <p:cNvPr id="24" name="Text 22"/>
+          <p:cNvPr id="24" name="Text 19"/>
           <p:cNvSpPr txBox="1"/>
           <p:nvPr/>
         </p:nvSpPr>

</xml_diff>